<commit_message>
Catchier presentation title and subtitle
Co-authored-by: Anacreo <44336100+Anacreo@users.noreply.github.com>
</commit_message>
<xml_diff>
--- a/presentation/NoTSUG-2026-SAS-AI.pptx
+++ b/presentation/NoTSUG-2026-SAS-AI.pptx
@@ -3226,7 +3226,7 @@
                 </a:solidFill>
                 <a:latin typeface="Calibri"/>
               </a:rPr>
-              <a:t>SAS + AI</a:t>
+              <a:t>Teach SAS to Read Minds</a:t>
             </a:r>
           </a:p>
         </p:txBody>
@@ -3265,7 +3265,7 @@
                 </a:solidFill>
                 <a:latin typeface="Calibri"/>
               </a:rPr>
-              <a:t>Calling an LLM from SAS, comparing engines and cost, and building SAS code in GitHub</a:t>
+              <a:t>Claude, PROC HTTP, and a Price Tag: which AI engine is worth the tokens, and how GitHub ships it to SAS Studio</a:t>
             </a:r>
           </a:p>
           <a:p>

</xml_diff>

<commit_message>
Reword agenda to match new title
Co-authored-by: Anacreo <44336100+Anacreo@users.noreply.github.com>
</commit_message>
<xml_diff>
--- a/presentation/NoTSUG-2026-SAS-AI.pptx
+++ b/presentation/NoTSUG-2026-SAS-AI.pptx
@@ -7871,13 +7871,13 @@
           <a:p>
             <a:pPr/>
             <a:r>
-              <a:rPr sz="2200">
+              <a:rPr sz="2200" b="0">
                 <a:solidFill>
                   <a:srgbClr val="444F5A"/>
                 </a:solidFill>
                 <a:latin typeface="Calibri"/>
               </a:rPr>
-              <a:t>1. The problem: free text SAS can't quantify</a:t>
+              <a:t>1. The mind-reading problem: free text SAS can't quantify</a:t>
             </a:r>
           </a:p>
         </p:txBody>
@@ -7906,31 +7906,13 @@
           <a:p>
             <a:pPr/>
             <a:r>
-              <a:rPr sz="2200">
+              <a:rPr sz="2200" b="0">
                 <a:solidFill>
                   <a:srgbClr val="444F5A"/>
                 </a:solidFill>
                 <a:latin typeface="Calibri"/>
               </a:rPr>
-              <a:t>2. Project structure (</a:t>
-            </a:r>
-            <a:r>
-              <a:rPr sz="2200">
-                <a:solidFill>
-                  <a:srgbClr val="1F78C8"/>
-                </a:solidFill>
-                <a:latin typeface="Consolas"/>
-              </a:rPr>
-              <a:t>sas/</a:t>
-            </a:r>
-            <a:r>
-              <a:rPr sz="2200">
-                <a:solidFill>
-                  <a:srgbClr val="444F5A"/>
-                </a:solidFill>
-                <a:latin typeface="Calibri"/>
-              </a:rPr>
-              <a:t>)</a:t>
+              <a:t>2. The setup: a SAS Studio project, built in GitHub</a:t>
             </a:r>
           </a:p>
         </p:txBody>
@@ -7959,22 +7941,13 @@
           <a:p>
             <a:pPr/>
             <a:r>
-              <a:rPr sz="2200">
+              <a:rPr sz="2200" b="0">
                 <a:solidFill>
                   <a:srgbClr val="444F5A"/>
                 </a:solidFill>
                 <a:latin typeface="Calibri"/>
               </a:rPr>
-              <a:t>3. Calling the LLM with </a:t>
-            </a:r>
-            <a:r>
-              <a:rPr sz="2200">
-                <a:solidFill>
-                  <a:srgbClr val="1F78C8"/>
-                </a:solidFill>
-                <a:latin typeface="Consolas"/>
-              </a:rPr>
-              <a:t>PROC HTTP</a:t>
+              <a:t>3. Asking Claude: PROC HTTP calls from SAS</a:t>
             </a:r>
           </a:p>
         </p:txBody>
@@ -8003,13 +7976,13 @@
           <a:p>
             <a:pPr/>
             <a:r>
-              <a:rPr sz="2200">
+              <a:rPr sz="2200" b="0">
                 <a:solidFill>
                   <a:srgbClr val="444F5A"/>
                 </a:solidFill>
                 <a:latin typeface="Calibri"/>
               </a:rPr>
-              <a:t>4. Parsing responses</a:t>
+              <a:t>4. Decoding the answer: parsing JSON back into data</a:t>
             </a:r>
           </a:p>
         </p:txBody>
@@ -8038,22 +8011,13 @@
           <a:p>
             <a:pPr/>
             <a:r>
-              <a:rPr sz="2200">
+              <a:rPr sz="2200" b="0">
                 <a:solidFill>
                   <a:srgbClr val="444F5A"/>
                 </a:solidFill>
                 <a:latin typeface="Calibri"/>
               </a:rPr>
-              <a:t>5. Comparing engines: accuracy, calibration, </a:t>
-            </a:r>
-            <a:r>
-              <a:rPr sz="2200" b="1">
-                <a:solidFill>
-                  <a:srgbClr val="444F5A"/>
-                </a:solidFill>
-                <a:latin typeface="Calibri"/>
-              </a:rPr>
-              <a:t>cost</a:t>
+              <a:t>5. Which mind is worth the tokens? Accuracy, calibration, and cost</a:t>
             </a:r>
           </a:p>
         </p:txBody>
@@ -8082,13 +8046,13 @@
           <a:p>
             <a:pPr/>
             <a:r>
-              <a:rPr sz="2200">
+              <a:rPr sz="2200" b="0">
                 <a:solidFill>
                   <a:srgbClr val="444F5A"/>
                 </a:solidFill>
                 <a:latin typeface="Calibri"/>
               </a:rPr>
-              <a:t>6. GitHub building the code and feeding SAS Studio</a:t>
+              <a:t>6. From GitHub to SAS Studio: shipping the code</a:t>
             </a:r>
           </a:p>
         </p:txBody>
@@ -8117,13 +8081,13 @@
           <a:p>
             <a:pPr/>
             <a:r>
-              <a:rPr sz="2200">
+              <a:rPr sz="2200" b="0">
                 <a:solidFill>
                   <a:srgbClr val="444F5A"/>
                 </a:solidFill>
                 <a:latin typeface="Calibri"/>
               </a:rPr>
-              <a:t>7. Lessons and Q&amp;A</a:t>
+              <a:t>7. Lessons learned and Q&amp;A</a:t>
             </a:r>
           </a:p>
         </p:txBody>

</xml_diff>